<commit_message>
Adopt Outfit A2 identity across brand guide and media
</commit_message>
<xml_diff>
--- a/Card_Evento_Kleber_Editavel.pptx
+++ b/Card_Evento_Kleber_Editavel.pptx
@@ -502,12 +502,12 @@
           <a:lstStyle/>
           <a:p>
             <a:r>
-              <a:t>Template NeuralMind.AI com fundo fiel ao HTML/CSS e textos editáveis.</a:t>
-            </a:r>
-          </a:p>
-          <a:p>
-            <a:r>
-              <a:t>Para máxima fidelidade no PowerPoint, instale a família NeuralMind Sans Square.</a:t>
+              <a:t>Template NeuralMind.ai com fundo fiel ao HTML/CSS e textos editáveis.</a:t>
+            </a:r>
+          </a:p>
+          <a:p>
+            <a:r>
+              <a:t>Para máxima fidelidade no PowerPoint, instale as famílias Outfit e Urbanist.</a:t>
             </a:r>
           </a:p>
         </p:txBody>
@@ -3572,7 +3572,7 @@
                 <a:solidFill>
                   <a:srgbClr val="EF476F"/>
                 </a:solidFill>
-                <a:latin typeface="NeuralMind Sans Square"/>
+                <a:latin typeface="Outfit"/>
               </a:rPr>
               <a:t>EVENTO</a:t>
             </a:r>
@@ -3615,7 +3615,7 @@
                 <a:solidFill>
                   <a:srgbClr val="FFFFFC"/>
                 </a:solidFill>
-                <a:latin typeface="NeuralMind Sans Square"/>
+                <a:latin typeface="Outfit"/>
               </a:rPr>
               <a:t>Data · horário</a:t>
             </a:r>
@@ -3658,7 +3658,7 @@
                 <a:solidFill>
                   <a:srgbClr val="EF476F"/>
                 </a:solidFill>
-                <a:latin typeface="NeuralMind Sans Square"/>
+                <a:latin typeface="Outfit"/>
               </a:rPr>
               <a:t>PARTICIPAÇÃO CONFIRMADA</a:t>
             </a:r>
@@ -3697,15 +3697,15 @@
               </a:spcAft>
             </a:pPr>
             <a:r>
-              <a:rPr lang="pt-BR" sz="4800" b="0">
+              <a:rPr lang="pt-BR" sz="4000" b="0">
                 <a:solidFill>
                   <a:srgbClr val="FFFFFC"/>
                 </a:solidFill>
-                <a:latin typeface="NeuralMind Sans Square"/>
+                <a:latin typeface="Outfit"/>
               </a:rPr>
               <a:t>Tema da</a:t>
             </a:r>
-            <a:endParaRPr lang="pt-BR" sz="4800"/>
+            <a:endParaRPr lang="pt-BR" sz="4000"/>
           </a:p>
           <a:p>
             <a:pPr algn="l">
@@ -3717,15 +3717,15 @@
               </a:spcAft>
             </a:pPr>
             <a:r>
-              <a:rPr lang="pt-BR" sz="4800" b="0">
+              <a:rPr lang="pt-BR" sz="4000" b="0">
                 <a:solidFill>
                   <a:srgbClr val="FFFFFC"/>
                 </a:solidFill>
-                <a:latin typeface="NeuralMind Sans Square"/>
+                <a:latin typeface="Outfit"/>
               </a:rPr>
               <a:t>participação</a:t>
             </a:r>
-            <a:endParaRPr lang="pt-BR" sz="4800"/>
+            <a:endParaRPr lang="pt-BR" sz="4000"/>
           </a:p>
           <a:p>
             <a:pPr algn="l">
@@ -3737,15 +3737,15 @@
               </a:spcAft>
             </a:pPr>
             <a:r>
-              <a:rPr lang="pt-BR" sz="4800" b="0">
+              <a:rPr lang="pt-BR" sz="4000" b="0">
                 <a:solidFill>
                   <a:srgbClr val="FFFFFC"/>
                 </a:solidFill>
-                <a:latin typeface="NeuralMind Sans Square"/>
+                <a:latin typeface="Outfit"/>
               </a:rPr>
               <a:t>no evento.</a:t>
             </a:r>
-            <a:endParaRPr lang="pt-BR" sz="4800"/>
+            <a:endParaRPr lang="pt-BR" sz="4000"/>
           </a:p>
         </p:txBody>
       </p:sp>
@@ -3784,7 +3784,7 @@
                 <a:solidFill>
                   <a:srgbClr val="FFFFFC"/>
                 </a:solidFill>
-                <a:latin typeface="NeuralMind Sans Square"/>
+                <a:latin typeface="Outfit"/>
               </a:rPr>
               <a:t>Kleber Edurado</a:t>
             </a:r>
@@ -3804,7 +3804,7 @@
                 <a:solidFill>
                   <a:srgbClr val="FFFFFC"/>
                 </a:solidFill>
-                <a:latin typeface="NeuralMind Sans Square"/>
+                <a:latin typeface="Outfit"/>
               </a:rPr>
               <a:t>Vicente dos Santos</a:t>
             </a:r>
@@ -3847,7 +3847,7 @@
                 <a:solidFill>
                   <a:srgbClr val="C8C0CD"/>
                 </a:solidFill>
-                <a:latin typeface="NeuralMind Sans Square"/>
+                <a:latin typeface="Outfit"/>
               </a:rPr>
               <a:t>HEAD DE INOVAÇÃO, PRODUTOS E</a:t>
             </a:r>
@@ -3867,7 +3867,7 @@
                 <a:solidFill>
                   <a:srgbClr val="C8C0CD"/>
                 </a:solidFill>
-                <a:latin typeface="NeuralMind Sans Square"/>
+                <a:latin typeface="Outfit"/>
               </a:rPr>
               <a:t>DESENVOLVIMENTO DE NEGÓCIOS</a:t>
             </a:r>
@@ -3910,7 +3910,7 @@
                 <a:solidFill>
                   <a:srgbClr val="C8C0CD"/>
                 </a:solidFill>
-                <a:latin typeface="NeuralMind Sans Square"/>
+                <a:latin typeface="Outfit"/>
               </a:rPr>
               <a:t>NOME DO EVENTO · LOCAL</a:t>
             </a:r>

</xml_diff>